<commit_message>
Déploiement : GitHub Pages activé, README finalisé et présentation PowerPoint ajoutée
</commit_message>
<xml_diff>
--- a/docs/AWA_SY_PRESENTATION.pptx
+++ b/docs/AWA_SY_PRESENTATION.pptx
@@ -121,7 +121,7 @@
             <a:srgbClr val="A4A3A4"/>
           </p15:clr>
         </p15:guide>
-        <p15:guide id="2" pos="2880">
+        <p15:guide id="2" pos="2865" userDrawn="1">
           <p15:clr>
             <a:srgbClr val="A4A3A4"/>
           </p15:clr>
@@ -311,7 +311,7 @@
           <a:p>
             <a:fld id="{5BCAD085-E8A6-8845-BD4E-CB4CCA059FC4}" type="datetimeFigureOut">
               <a:rPr lang="en-US" smtClean="0"/>
-              <a:t>7/2/2026</a:t>
+              <a:t>7/3/2026</a:t>
             </a:fld>
             <a:endParaRPr lang="en-US"/>
           </a:p>
@@ -369,6 +369,18 @@
   <p:clrMapOvr>
     <a:masterClrMapping/>
   </p:clrMapOvr>
+  <mc:AlternateContent xmlns:mc="http://schemas.openxmlformats.org/markup-compatibility/2006">
+    <mc:Choice xmlns:p14="http://schemas.microsoft.com/office/powerpoint/2010/main" Requires="p14">
+      <p:transition spd="med" p14:dur="700">
+        <p:fade/>
+      </p:transition>
+    </mc:Choice>
+    <mc:Fallback>
+      <p:transition spd="med">
+        <p:fade/>
+      </p:transition>
+    </mc:Fallback>
+  </mc:AlternateContent>
 </p:sldLayout>
 </file>
 
@@ -479,7 +491,7 @@
           <a:p>
             <a:fld id="{5BCAD085-E8A6-8845-BD4E-CB4CCA059FC4}" type="datetimeFigureOut">
               <a:rPr lang="en-US" smtClean="0"/>
-              <a:t>7/2/2026</a:t>
+              <a:t>7/3/2026</a:t>
             </a:fld>
             <a:endParaRPr lang="en-US"/>
           </a:p>
@@ -537,6 +549,18 @@
   <p:clrMapOvr>
     <a:masterClrMapping/>
   </p:clrMapOvr>
+  <mc:AlternateContent xmlns:mc="http://schemas.openxmlformats.org/markup-compatibility/2006">
+    <mc:Choice xmlns:p14="http://schemas.microsoft.com/office/powerpoint/2010/main" Requires="p14">
+      <p:transition spd="med" p14:dur="700">
+        <p:fade/>
+      </p:transition>
+    </mc:Choice>
+    <mc:Fallback>
+      <p:transition spd="med">
+        <p:fade/>
+      </p:transition>
+    </mc:Fallback>
+  </mc:AlternateContent>
 </p:sldLayout>
 </file>
 
@@ -657,7 +681,7 @@
           <a:p>
             <a:fld id="{5BCAD085-E8A6-8845-BD4E-CB4CCA059FC4}" type="datetimeFigureOut">
               <a:rPr lang="en-US" smtClean="0"/>
-              <a:t>7/2/2026</a:t>
+              <a:t>7/3/2026</a:t>
             </a:fld>
             <a:endParaRPr lang="en-US"/>
           </a:p>
@@ -715,6 +739,18 @@
   <p:clrMapOvr>
     <a:masterClrMapping/>
   </p:clrMapOvr>
+  <mc:AlternateContent xmlns:mc="http://schemas.openxmlformats.org/markup-compatibility/2006">
+    <mc:Choice xmlns:p14="http://schemas.microsoft.com/office/powerpoint/2010/main" Requires="p14">
+      <p:transition spd="med" p14:dur="700">
+        <p:fade/>
+      </p:transition>
+    </mc:Choice>
+    <mc:Fallback>
+      <p:transition spd="med">
+        <p:fade/>
+      </p:transition>
+    </mc:Fallback>
+  </mc:AlternateContent>
 </p:sldLayout>
 </file>
 
@@ -825,7 +861,7 @@
           <a:p>
             <a:fld id="{5BCAD085-E8A6-8845-BD4E-CB4CCA059FC4}" type="datetimeFigureOut">
               <a:rPr lang="en-US" smtClean="0"/>
-              <a:t>7/2/2026</a:t>
+              <a:t>7/3/2026</a:t>
             </a:fld>
             <a:endParaRPr lang="en-US"/>
           </a:p>
@@ -883,6 +919,18 @@
   <p:clrMapOvr>
     <a:masterClrMapping/>
   </p:clrMapOvr>
+  <mc:AlternateContent xmlns:mc="http://schemas.openxmlformats.org/markup-compatibility/2006">
+    <mc:Choice xmlns:p14="http://schemas.microsoft.com/office/powerpoint/2010/main" Requires="p14">
+      <p:transition spd="med" p14:dur="700">
+        <p:fade/>
+      </p:transition>
+    </mc:Choice>
+    <mc:Fallback>
+      <p:transition spd="med">
+        <p:fade/>
+      </p:transition>
+    </mc:Fallback>
+  </mc:AlternateContent>
 </p:sldLayout>
 </file>
 
@@ -1070,7 +1118,7 @@
           <a:p>
             <a:fld id="{5BCAD085-E8A6-8845-BD4E-CB4CCA059FC4}" type="datetimeFigureOut">
               <a:rPr lang="en-US" smtClean="0"/>
-              <a:t>7/2/2026</a:t>
+              <a:t>7/3/2026</a:t>
             </a:fld>
             <a:endParaRPr lang="en-US"/>
           </a:p>
@@ -1128,6 +1176,18 @@
   <p:clrMapOvr>
     <a:masterClrMapping/>
   </p:clrMapOvr>
+  <mc:AlternateContent xmlns:mc="http://schemas.openxmlformats.org/markup-compatibility/2006">
+    <mc:Choice xmlns:p14="http://schemas.microsoft.com/office/powerpoint/2010/main" Requires="p14">
+      <p:transition spd="med" p14:dur="700">
+        <p:fade/>
+      </p:transition>
+    </mc:Choice>
+    <mc:Fallback>
+      <p:transition spd="med">
+        <p:fade/>
+      </p:transition>
+    </mc:Fallback>
+  </mc:AlternateContent>
 </p:sldLayout>
 </file>
 
@@ -1355,7 +1415,7 @@
           <a:p>
             <a:fld id="{5BCAD085-E8A6-8845-BD4E-CB4CCA059FC4}" type="datetimeFigureOut">
               <a:rPr lang="en-US" smtClean="0"/>
-              <a:t>7/2/2026</a:t>
+              <a:t>7/3/2026</a:t>
             </a:fld>
             <a:endParaRPr lang="en-US"/>
           </a:p>
@@ -1413,6 +1473,18 @@
   <p:clrMapOvr>
     <a:masterClrMapping/>
   </p:clrMapOvr>
+  <mc:AlternateContent xmlns:mc="http://schemas.openxmlformats.org/markup-compatibility/2006">
+    <mc:Choice xmlns:p14="http://schemas.microsoft.com/office/powerpoint/2010/main" Requires="p14">
+      <p:transition spd="med" p14:dur="700">
+        <p:fade/>
+      </p:transition>
+    </mc:Choice>
+    <mc:Fallback>
+      <p:transition spd="med">
+        <p:fade/>
+      </p:transition>
+    </mc:Fallback>
+  </mc:AlternateContent>
 </p:sldLayout>
 </file>
 
@@ -1774,7 +1846,7 @@
           <a:p>
             <a:fld id="{5BCAD085-E8A6-8845-BD4E-CB4CCA059FC4}" type="datetimeFigureOut">
               <a:rPr lang="en-US" smtClean="0"/>
-              <a:t>7/2/2026</a:t>
+              <a:t>7/3/2026</a:t>
             </a:fld>
             <a:endParaRPr lang="en-US"/>
           </a:p>
@@ -1832,6 +1904,18 @@
   <p:clrMapOvr>
     <a:masterClrMapping/>
   </p:clrMapOvr>
+  <mc:AlternateContent xmlns:mc="http://schemas.openxmlformats.org/markup-compatibility/2006">
+    <mc:Choice xmlns:p14="http://schemas.microsoft.com/office/powerpoint/2010/main" Requires="p14">
+      <p:transition spd="med" p14:dur="700">
+        <p:fade/>
+      </p:transition>
+    </mc:Choice>
+    <mc:Fallback>
+      <p:transition spd="med">
+        <p:fade/>
+      </p:transition>
+    </mc:Fallback>
+  </mc:AlternateContent>
 </p:sldLayout>
 </file>
 
@@ -1891,7 +1975,7 @@
           <a:p>
             <a:fld id="{5BCAD085-E8A6-8845-BD4E-CB4CCA059FC4}" type="datetimeFigureOut">
               <a:rPr lang="en-US" smtClean="0"/>
-              <a:t>7/2/2026</a:t>
+              <a:t>7/3/2026</a:t>
             </a:fld>
             <a:endParaRPr lang="en-US"/>
           </a:p>
@@ -1949,6 +2033,18 @@
   <p:clrMapOvr>
     <a:masterClrMapping/>
   </p:clrMapOvr>
+  <mc:AlternateContent xmlns:mc="http://schemas.openxmlformats.org/markup-compatibility/2006">
+    <mc:Choice xmlns:p14="http://schemas.microsoft.com/office/powerpoint/2010/main" Requires="p14">
+      <p:transition spd="med" p14:dur="700">
+        <p:fade/>
+      </p:transition>
+    </mc:Choice>
+    <mc:Fallback>
+      <p:transition spd="med">
+        <p:fade/>
+      </p:transition>
+    </mc:Fallback>
+  </mc:AlternateContent>
 </p:sldLayout>
 </file>
 
@@ -1986,7 +2082,7 @@
           <a:p>
             <a:fld id="{5BCAD085-E8A6-8845-BD4E-CB4CCA059FC4}" type="datetimeFigureOut">
               <a:rPr lang="en-US" smtClean="0"/>
-              <a:t>7/2/2026</a:t>
+              <a:t>7/3/2026</a:t>
             </a:fld>
             <a:endParaRPr lang="en-US"/>
           </a:p>
@@ -2044,6 +2140,18 @@
   <p:clrMapOvr>
     <a:masterClrMapping/>
   </p:clrMapOvr>
+  <mc:AlternateContent xmlns:mc="http://schemas.openxmlformats.org/markup-compatibility/2006">
+    <mc:Choice xmlns:p14="http://schemas.microsoft.com/office/powerpoint/2010/main" Requires="p14">
+      <p:transition spd="med" p14:dur="700">
+        <p:fade/>
+      </p:transition>
+    </mc:Choice>
+    <mc:Fallback>
+      <p:transition spd="med">
+        <p:fade/>
+      </p:transition>
+    </mc:Fallback>
+  </mc:AlternateContent>
 </p:sldLayout>
 </file>
 
@@ -2261,7 +2369,7 @@
           <a:p>
             <a:fld id="{5BCAD085-E8A6-8845-BD4E-CB4CCA059FC4}" type="datetimeFigureOut">
               <a:rPr lang="en-US" smtClean="0"/>
-              <a:t>7/2/2026</a:t>
+              <a:t>7/3/2026</a:t>
             </a:fld>
             <a:endParaRPr lang="en-US"/>
           </a:p>
@@ -2319,6 +2427,18 @@
   <p:clrMapOvr>
     <a:masterClrMapping/>
   </p:clrMapOvr>
+  <mc:AlternateContent xmlns:mc="http://schemas.openxmlformats.org/markup-compatibility/2006">
+    <mc:Choice xmlns:p14="http://schemas.microsoft.com/office/powerpoint/2010/main" Requires="p14">
+      <p:transition spd="med" p14:dur="700">
+        <p:fade/>
+      </p:transition>
+    </mc:Choice>
+    <mc:Fallback>
+      <p:transition spd="med">
+        <p:fade/>
+      </p:transition>
+    </mc:Fallback>
+  </mc:AlternateContent>
 </p:sldLayout>
 </file>
 
@@ -2513,7 +2633,7 @@
           <a:p>
             <a:fld id="{5BCAD085-E8A6-8845-BD4E-CB4CCA059FC4}" type="datetimeFigureOut">
               <a:rPr lang="en-US" smtClean="0"/>
-              <a:t>7/2/2026</a:t>
+              <a:t>7/3/2026</a:t>
             </a:fld>
             <a:endParaRPr lang="en-US"/>
           </a:p>
@@ -2571,6 +2691,18 @@
   <p:clrMapOvr>
     <a:masterClrMapping/>
   </p:clrMapOvr>
+  <mc:AlternateContent xmlns:mc="http://schemas.openxmlformats.org/markup-compatibility/2006">
+    <mc:Choice xmlns:p14="http://schemas.microsoft.com/office/powerpoint/2010/main" Requires="p14">
+      <p:transition spd="med" p14:dur="700">
+        <p:fade/>
+      </p:transition>
+    </mc:Choice>
+    <mc:Fallback>
+      <p:transition spd="med">
+        <p:fade/>
+      </p:transition>
+    </mc:Fallback>
+  </mc:AlternateContent>
 </p:sldLayout>
 </file>
 
@@ -2724,7 +2856,7 @@
           <a:p>
             <a:fld id="{5BCAD085-E8A6-8845-BD4E-CB4CCA059FC4}" type="datetimeFigureOut">
               <a:rPr lang="en-US" smtClean="0"/>
-              <a:t>7/2/2026</a:t>
+              <a:t>7/3/2026</a:t>
             </a:fld>
             <a:endParaRPr lang="en-US"/>
           </a:p>
@@ -2829,6 +2961,18 @@
     <p:sldLayoutId id="2147483658" r:id="rId10"/>
     <p:sldLayoutId id="2147483659" r:id="rId11"/>
   </p:sldLayoutIdLst>
+  <mc:AlternateContent xmlns:mc="http://schemas.openxmlformats.org/markup-compatibility/2006">
+    <mc:Choice xmlns:p14="http://schemas.microsoft.com/office/powerpoint/2010/main" Requires="p14">
+      <p:transition spd="med" p14:dur="700">
+        <p:fade/>
+      </p:transition>
+    </mc:Choice>
+    <mc:Fallback>
+      <p:transition spd="med">
+        <p:fade/>
+      </p:transition>
+    </mc:Fallback>
+  </mc:AlternateContent>
   <p:txStyles>
     <p:titleStyle>
       <a:lvl1pPr algn="ctr" defTabSz="457200" rtl="0" eaLnBrk="1" latinLnBrk="0" hangingPunct="1">
@@ -3551,6 +3695,18 @@
   <p:clrMapOvr>
     <a:masterClrMapping/>
   </p:clrMapOvr>
+  <mc:AlternateContent xmlns:mc="http://schemas.openxmlformats.org/markup-compatibility/2006">
+    <mc:Choice xmlns:p14="http://schemas.microsoft.com/office/powerpoint/2010/main" Requires="p14">
+      <p:transition spd="med" p14:dur="700">
+        <p:fade/>
+      </p:transition>
+    </mc:Choice>
+    <mc:Fallback>
+      <p:transition spd="med">
+        <p:fade/>
+      </p:transition>
+    </mc:Fallback>
+  </mc:AlternateContent>
 </p:sld>
 </file>
 
@@ -3668,7 +3824,7 @@
         </p:nvSpPr>
         <p:spPr>
           <a:xfrm>
-            <a:off x="457200" y="2011680"/>
+            <a:off x="457200" y="1415337"/>
             <a:ext cx="11277295" cy="365760"/>
           </a:xfrm>
           <a:prstGeom prst="rect">
@@ -3827,6 +3983,18 @@
   <p:clrMapOvr>
     <a:masterClrMapping/>
   </p:clrMapOvr>
+  <mc:AlternateContent xmlns:mc="http://schemas.openxmlformats.org/markup-compatibility/2006">
+    <mc:Choice xmlns:p14="http://schemas.microsoft.com/office/powerpoint/2010/main" Requires="p14">
+      <p:transition spd="med" p14:dur="700">
+        <p:fade/>
+      </p:transition>
+    </mc:Choice>
+    <mc:Fallback>
+      <p:transition spd="med">
+        <p:fade/>
+      </p:transition>
+    </mc:Fallback>
+  </mc:AlternateContent>
 </p:sld>
 </file>
 
@@ -4319,7 +4487,7 @@
         </p:nvSpPr>
         <p:spPr>
           <a:xfrm>
-            <a:off x="2194560" y="4434840"/>
+            <a:off x="2194560" y="4514352"/>
             <a:ext cx="4114800" cy="548640"/>
           </a:xfrm>
           <a:prstGeom prst="rect">
@@ -4341,6 +4509,7 @@
               </a:defRPr>
             </a:pPr>
             <a:r>
+              <a:rPr dirty="0"/>
               <a:t>Technologies &amp; points techniques</a:t>
             </a:r>
           </a:p>
@@ -4696,7 +4865,7 @@
         </p:nvSpPr>
         <p:spPr>
           <a:xfrm>
-            <a:off x="5852160" y="2377440"/>
+            <a:off x="6170208" y="2377440"/>
             <a:ext cx="36576" cy="3840480"/>
           </a:xfrm>
           <a:prstGeom prst="rect">
@@ -4737,6 +4906,18 @@
   <p:clrMapOvr>
     <a:masterClrMapping/>
   </p:clrMapOvr>
+  <mc:AlternateContent xmlns:mc="http://schemas.openxmlformats.org/markup-compatibility/2006">
+    <mc:Choice xmlns:p14="http://schemas.microsoft.com/office/powerpoint/2010/main" Requires="p14">
+      <p:transition spd="med" p14:dur="700">
+        <p:fade/>
+      </p:transition>
+    </mc:Choice>
+    <mc:Fallback>
+      <p:transition spd="med">
+        <p:fade/>
+      </p:transition>
+    </mc:Fallback>
+  </mc:AlternateContent>
 </p:sld>
 </file>
 
@@ -5596,6 +5777,18 @@
   <p:clrMapOvr>
     <a:masterClrMapping/>
   </p:clrMapOvr>
+  <mc:AlternateContent xmlns:mc="http://schemas.openxmlformats.org/markup-compatibility/2006">
+    <mc:Choice xmlns:p14="http://schemas.microsoft.com/office/powerpoint/2010/main" Requires="p14">
+      <p:transition spd="med" p14:dur="700">
+        <p:fade/>
+      </p:transition>
+    </mc:Choice>
+    <mc:Fallback>
+      <p:transition spd="med">
+        <p:fade/>
+      </p:transition>
+    </mc:Fallback>
+  </mc:AlternateContent>
 </p:sld>
 </file>
 
@@ -6234,6 +6427,18 @@
   <p:clrMapOvr>
     <a:masterClrMapping/>
   </p:clrMapOvr>
+  <mc:AlternateContent xmlns:mc="http://schemas.openxmlformats.org/markup-compatibility/2006">
+    <mc:Choice xmlns:p14="http://schemas.microsoft.com/office/powerpoint/2010/main" Requires="p14">
+      <p:transition spd="med" p14:dur="700">
+        <p:fade/>
+      </p:transition>
+    </mc:Choice>
+    <mc:Fallback>
+      <p:transition spd="med">
+        <p:fade/>
+      </p:transition>
+    </mc:Fallback>
+  </mc:AlternateContent>
 </p:sld>
 </file>
 
@@ -7433,6 +7638,18 @@
   <p:clrMapOvr>
     <a:masterClrMapping/>
   </p:clrMapOvr>
+  <mc:AlternateContent xmlns:mc="http://schemas.openxmlformats.org/markup-compatibility/2006">
+    <mc:Choice xmlns:p14="http://schemas.microsoft.com/office/powerpoint/2010/main" Requires="p14">
+      <p:transition spd="med" p14:dur="700">
+        <p:fade/>
+      </p:transition>
+    </mc:Choice>
+    <mc:Fallback>
+      <p:transition spd="med">
+        <p:fade/>
+      </p:transition>
+    </mc:Fallback>
+  </mc:AlternateContent>
 </p:sld>
 </file>
 
@@ -7550,8 +7767,8 @@
         </p:nvSpPr>
         <p:spPr>
           <a:xfrm>
-            <a:off x="914400" y="2651760"/>
-            <a:ext cx="3108960" cy="731520"/>
+            <a:off x="894094" y="2651760"/>
+            <a:ext cx="3149580" cy="461665"/>
           </a:xfrm>
           <a:prstGeom prst="rect">
             <a:avLst/>
@@ -7572,8 +7789,14 @@
               </a:defRPr>
             </a:pPr>
             <a:r>
-              <a:t>🎨 Frontend</a:t>
-            </a:r>
+              <a:rPr dirty="0"/>
+              <a:t>🎨</a:t>
+            </a:r>
+            <a:r>
+              <a:rPr lang="fr-FR" dirty="0"/>
+              <a:t>Interface Utilisateur</a:t>
+            </a:r>
+            <a:endParaRPr dirty="0"/>
           </a:p>
         </p:txBody>
       </p:sp>
@@ -8102,6 +8325,18 @@
   <p:clrMapOvr>
     <a:masterClrMapping/>
   </p:clrMapOvr>
+  <mc:AlternateContent xmlns:mc="http://schemas.openxmlformats.org/markup-compatibility/2006">
+    <mc:Choice xmlns:p14="http://schemas.microsoft.com/office/powerpoint/2010/main" Requires="p14">
+      <p:transition spd="med" p14:dur="700">
+        <p:fade/>
+      </p:transition>
+    </mc:Choice>
+    <mc:Fallback>
+      <p:transition spd="med">
+        <p:fade/>
+      </p:transition>
+    </mc:Fallback>
+  </mc:AlternateContent>
 </p:sld>
 </file>
 
@@ -8864,6 +9099,18 @@
   <p:clrMapOvr>
     <a:masterClrMapping/>
   </p:clrMapOvr>
+  <mc:AlternateContent xmlns:mc="http://schemas.openxmlformats.org/markup-compatibility/2006">
+    <mc:Choice xmlns:p14="http://schemas.microsoft.com/office/powerpoint/2010/main" Requires="p14">
+      <p:transition spd="med" p14:dur="700">
+        <p:fade/>
+      </p:transition>
+    </mc:Choice>
+    <mc:Fallback>
+      <p:transition spd="med">
+        <p:fade/>
+      </p:transition>
+    </mc:Fallback>
+  </mc:AlternateContent>
 </p:sld>
 </file>
 
@@ -8900,8 +9147,8 @@
         </p:nvSpPr>
         <p:spPr>
           <a:xfrm>
-            <a:off x="457200" y="365760"/>
-            <a:ext cx="11277295" cy="1371600"/>
+            <a:off x="2609574" y="365760"/>
+            <a:ext cx="6972551" cy="769441"/>
           </a:xfrm>
           <a:prstGeom prst="rect">
             <a:avLst/>
@@ -8922,7 +9169,16 @@
               </a:defRPr>
             </a:pPr>
             <a:r>
-              <a:t>GitHub &amp; versioning</a:t>
+              <a:rPr dirty="0"/>
+              <a:t>GitHub &amp;</a:t>
+            </a:r>
+            <a:r>
+              <a:rPr lang="fr-FR" dirty="0"/>
+              <a:t> Gestion de </a:t>
+            </a:r>
+            <a:r>
+              <a:rPr dirty="0"/>
+              <a:t> version</a:t>
             </a:r>
           </a:p>
         </p:txBody>
@@ -9330,6 +9586,18 @@
   <p:clrMapOvr>
     <a:masterClrMapping/>
   </p:clrMapOvr>
+  <mc:AlternateContent xmlns:mc="http://schemas.openxmlformats.org/markup-compatibility/2006">
+    <mc:Choice xmlns:p14="http://schemas.microsoft.com/office/powerpoint/2010/main" Requires="p14">
+      <p:transition spd="med" p14:dur="700">
+        <p:fade/>
+      </p:transition>
+    </mc:Choice>
+    <mc:Fallback>
+      <p:transition spd="med">
+        <p:fade/>
+      </p:transition>
+    </mc:Fallback>
+  </mc:AlternateContent>
 </p:sld>
 </file>
 
@@ -9366,7 +9634,7 @@
         </p:nvSpPr>
         <p:spPr>
           <a:xfrm>
-            <a:off x="457200" y="365760"/>
+            <a:off x="467139" y="365760"/>
             <a:ext cx="11277295" cy="1371600"/>
           </a:xfrm>
           <a:prstGeom prst="rect">
@@ -10158,6 +10426,18 @@
   <p:clrMapOvr>
     <a:masterClrMapping/>
   </p:clrMapOvr>
+  <mc:AlternateContent xmlns:mc="http://schemas.openxmlformats.org/markup-compatibility/2006">
+    <mc:Choice xmlns:p14="http://schemas.microsoft.com/office/powerpoint/2010/main" Requires="p14">
+      <p:transition spd="med" p14:dur="700">
+        <p:fade/>
+      </p:transition>
+    </mc:Choice>
+    <mc:Fallback>
+      <p:transition spd="med">
+        <p:fade/>
+      </p:transition>
+    </mc:Fallback>
+  </mc:AlternateContent>
 </p:sld>
 </file>
 

</xml_diff>